<commit_message>
report PPT: showdown-complete slide update
</commit_message>
<xml_diff>
--- a/report.pptx
+++ b/report.pptx
@@ -3352,7 +3352,7 @@
                 </a:solidFill>
                 <a:latin typeface="Microsoft YaHei"/>
               </a:rPr>
-              <a:t>• 干净对决 v2：14 局（含 worstcase 配额保守、ours_p 暂停变体）——产出图 20 与 7.4b 对照表</a:t>
+              <a:t>• 对决已定稿：14 局完整表 + 图 20 已入稿（v0.8）；链尾 show4/show5 做多轮复测</a:t>
             </a:r>
           </a:p>
           <a:p>
@@ -4849,7 +4849,7 @@
                 </a:solidFill>
                 <a:latin typeface="Microsoft YaHei"/>
               </a:rPr>
-              <a:t>• 在线对决（7 策略 × 2 相位，统一到达流与证据）：v1 中相位感知准入在对齐场景停在 8 台断档</a:t>
+              <a:t>• 完整 14 局在线对决（统一到达流与证据）：**ours/ours_p 是唯一在对齐相位停在已验证档位（8 台）的策略**，随机 16–20 台</a:t>
             </a:r>
           </a:p>
           <a:p>
@@ -4865,7 +4865,7 @@
                 </a:solidFill>
                 <a:latin typeface="Microsoft YaHei"/>
               </a:rPr>
-              <a:t>• 干净 14 局 v2 正在物理机运行；输出「安全接纳数 vs oracle」对照图与安全 VM-hours 表</a:t>
+              <a:t>• 对照：audible 式与 util80 在同步相位冲帽 40（客户 P5 崩至 16%）；fixed 同步 16 违主口径；worstcase/quantile 永远 8</a:t>
             </a:r>
           </a:p>
           <a:p>
@@ -4881,7 +4881,7 @@
                 </a:solidFill>
                 <a:latin typeface="Microsoft YaHei"/>
               </a:rPr>
-              <a:t>• 诚实口径：断档 ≠ 精确 oracle；零超接是安全下限，边界细扫点头前不主张命中</a:t>
+              <a:t>• 诚实口径：单局停点≠oracle；show4/show5 多轮复测与边界细扫在链尾自动跑</a:t>
             </a:r>
           </a:p>
         </p:txBody>

</xml_diff>